<commit_message>
feat(sprint3): integrate education pipeline with presentation engine
</commit_message>
<xml_diff>
--- a/output/web3_Carousel.pptx
+++ b/output/web3_Carousel.pptx
@@ -3337,7 +3337,7 @@
                 </a:solidFill>
                 <a:latin typeface="Calibri"/>
               </a:rPr>
-              <a:t>What Is Blockchain?</a:t>
+              <a:t>Artificial Intelligence</a:t>
             </a:r>
           </a:p>
         </p:txBody>
@@ -3372,7 +3372,7 @@
                 </a:solidFill>
                 <a:latin typeface="Calibri"/>
               </a:rPr>
-              <a:t>Blockchain is a decentralized digital ledger that records transactions securely.</a:t>
+              <a:t>General</a:t>
             </a:r>
           </a:p>
         </p:txBody>
@@ -3529,9 +3529,79 @@
           </a:p>
         </p:txBody>
       </p:sp>
+      <p:sp>
+        <p:nvSpPr>
+          <p:cNvPr id="3" name="TextBox 2"/>
+          <p:cNvSpPr txBox="1"/>
+          <p:nvPr/>
+        </p:nvSpPr>
+        <p:spPr>
+          <a:xfrm>
+            <a:off x="640080" y="548640"/>
+            <a:ext cx="5669280" cy="548640"/>
+          </a:xfrm>
+          <a:prstGeom prst="rect">
+            <a:avLst/>
+          </a:prstGeom>
+          <a:noFill/>
+        </p:spPr>
+        <p:txBody>
+          <a:bodyPr wrap="none">
+            <a:spAutoFit/>
+          </a:bodyPr>
+          <a:lstStyle/>
+          <a:p>
+            <a:pPr algn="l"/>
+            <a:r>
+              <a:rPr sz="2200" b="1">
+                <a:solidFill>
+                  <a:srgbClr val="141414"/>
+                </a:solidFill>
+                <a:latin typeface="Calibri"/>
+              </a:rPr>
+              <a:t>What is the concept?</a:t>
+            </a:r>
+          </a:p>
+        </p:txBody>
+      </p:sp>
+      <p:sp>
+        <p:nvSpPr>
+          <p:cNvPr id="4" name="TextBox 3"/>
+          <p:cNvSpPr txBox="1"/>
+          <p:nvPr/>
+        </p:nvSpPr>
+        <p:spPr>
+          <a:xfrm>
+            <a:off x="640080" y="1463040"/>
+            <a:ext cx="5669280" cy="3474720"/>
+          </a:xfrm>
+          <a:prstGeom prst="rect">
+            <a:avLst/>
+          </a:prstGeom>
+          <a:noFill/>
+        </p:spPr>
+        <p:txBody>
+          <a:bodyPr wrap="none">
+            <a:spAutoFit/>
+          </a:bodyPr>
+          <a:lstStyle/>
+          <a:p>
+            <a:pPr algn="l"/>
+            <a:r>
+              <a:rPr sz="1600" b="0">
+                <a:solidFill>
+                  <a:srgbClr val="141414"/>
+                </a:solidFill>
+                <a:latin typeface="Calibri"/>
+              </a:rPr>
+              <a:t>Artificial Intelligence is an important concept in modern technology.</a:t>
+            </a:r>
+          </a:p>
+        </p:txBody>
+      </p:sp>
       <p:pic>
         <p:nvPicPr>
-          <p:cNvPr id="3" name="Picture 2" descr="web3.png"/>
+          <p:cNvPr id="5" name="Picture 4" descr="web3.png"/>
           <p:cNvPicPr>
             <a:picLocks noChangeAspect="1"/>
           </p:cNvPicPr>
@@ -3545,7 +3615,7 @@
         </p:blipFill>
         <p:spPr>
           <a:xfrm>
-            <a:off x="548640" y="1371600"/>
+            <a:off x="7955279" y="1234440"/>
             <a:ext cx="3474720" cy="3474720"/>
           </a:xfrm>
           <a:prstGeom prst="rect">
@@ -3553,76 +3623,6 @@
           </a:prstGeom>
         </p:spPr>
       </p:pic>
-      <p:sp>
-        <p:nvSpPr>
-          <p:cNvPr id="4" name="TextBox 3"/>
-          <p:cNvSpPr txBox="1"/>
-          <p:nvPr/>
-        </p:nvSpPr>
-        <p:spPr>
-          <a:xfrm>
-            <a:off x="4572000" y="640080"/>
-            <a:ext cx="6400800" cy="548640"/>
-          </a:xfrm>
-          <a:prstGeom prst="rect">
-            <a:avLst/>
-          </a:prstGeom>
-          <a:noFill/>
-        </p:spPr>
-        <p:txBody>
-          <a:bodyPr wrap="none">
-            <a:spAutoFit/>
-          </a:bodyPr>
-          <a:lstStyle/>
-          <a:p>
-            <a:pPr algn="l"/>
-            <a:r>
-              <a:rPr sz="2200" b="1">
-                <a:solidFill>
-                  <a:srgbClr val="141414"/>
-                </a:solidFill>
-                <a:latin typeface="Calibri"/>
-              </a:rPr>
-              <a:t>Why Does Blockchain Matter?</a:t>
-            </a:r>
-          </a:p>
-        </p:txBody>
-      </p:sp>
-      <p:sp>
-        <p:nvSpPr>
-          <p:cNvPr id="5" name="TextBox 4"/>
-          <p:cNvSpPr txBox="1"/>
-          <p:nvPr/>
-        </p:nvSpPr>
-        <p:spPr>
-          <a:xfrm>
-            <a:off x="4572000" y="1554480"/>
-            <a:ext cx="6400800" cy="3291840"/>
-          </a:xfrm>
-          <a:prstGeom prst="rect">
-            <a:avLst/>
-          </a:prstGeom>
-          <a:noFill/>
-        </p:spPr>
-        <p:txBody>
-          <a:bodyPr wrap="none">
-            <a:spAutoFit/>
-          </a:bodyPr>
-          <a:lstStyle/>
-          <a:p>
-            <a:pPr algn="l"/>
-            <a:r>
-              <a:rPr sz="1600" b="0">
-                <a:solidFill>
-                  <a:srgbClr val="141414"/>
-                </a:solidFill>
-                <a:latin typeface="Calibri"/>
-              </a:rPr>
-              <a:t>It enables trust and transparency without relying on a central authority.</a:t>
-            </a:r>
-          </a:p>
-        </p:txBody>
-      </p:sp>
       <p:pic>
         <p:nvPicPr>
           <p:cNvPr id="6" name="Picture 5" descr="record.png"/>
@@ -3759,8 +3759,8 @@
         </p:nvSpPr>
         <p:spPr>
           <a:xfrm>
-            <a:off x="731520" y="640080"/>
-            <a:ext cx="4114800" cy="457200"/>
+            <a:off x="640080" y="548640"/>
+            <a:ext cx="5669280" cy="548640"/>
           </a:xfrm>
           <a:prstGeom prst="rect">
             <a:avLst/>
@@ -3775,62 +3775,27 @@
           <a:p>
             <a:pPr algn="l"/>
             <a:r>
-              <a:rPr sz="1200" b="1">
-                <a:solidFill>
-                  <a:srgbClr val="FF6600"/>
-                </a:solidFill>
-                <a:latin typeface="Calibri"/>
-              </a:rPr>
-              <a:t>KEY TAKEAWAY</a:t>
-            </a:r>
-          </a:p>
-        </p:txBody>
-      </p:sp>
-      <p:sp>
-        <p:nvSpPr>
-          <p:cNvPr id="4" name="TextBox 3"/>
-          <p:cNvSpPr txBox="1"/>
-          <p:nvPr/>
-        </p:nvSpPr>
-        <p:spPr>
-          <a:xfrm>
-            <a:off x="731520" y="1188720"/>
-            <a:ext cx="6583680" cy="731520"/>
-          </a:xfrm>
-          <a:prstGeom prst="rect">
-            <a:avLst/>
-          </a:prstGeom>
-          <a:noFill/>
-        </p:spPr>
-        <p:txBody>
-          <a:bodyPr wrap="none">
-            <a:spAutoFit/>
-          </a:bodyPr>
-          <a:lstStyle/>
-          <a:p>
-            <a:pPr algn="l"/>
-            <a:r>
-              <a:rPr sz="2400" b="1">
+              <a:rPr sz="2200" b="1">
                 <a:solidFill>
                   <a:srgbClr val="141414"/>
                 </a:solidFill>
                 <a:latin typeface="Calibri"/>
               </a:rPr>
-              <a:t>Common Applications</a:t>
-            </a:r>
-          </a:p>
-        </p:txBody>
-      </p:sp>
-      <p:sp>
-        <p:nvSpPr>
-          <p:cNvPr id="5" name="TextBox 4"/>
+              <a:t>Simple Explanation</a:t>
+            </a:r>
+          </a:p>
+        </p:txBody>
+      </p:sp>
+      <p:sp>
+        <p:nvSpPr>
+          <p:cNvPr id="4" name="TextBox 3"/>
           <p:cNvSpPr txBox="1"/>
           <p:nvPr/>
         </p:nvSpPr>
         <p:spPr>
           <a:xfrm>
-            <a:off x="731520" y="2194560"/>
-            <a:ext cx="6400800" cy="2377440"/>
+            <a:off x="640080" y="1463040"/>
+            <a:ext cx="5669280" cy="3474720"/>
           </a:xfrm>
           <a:prstGeom prst="rect">
             <a:avLst/>
@@ -3845,20 +3810,20 @@
           <a:p>
             <a:pPr algn="l"/>
             <a:r>
-              <a:rPr sz="1800" b="0">
+              <a:rPr sz="1600" b="0">
                 <a:solidFill>
                   <a:srgbClr val="141414"/>
                 </a:solidFill>
                 <a:latin typeface="Calibri"/>
               </a:rPr>
-              <a:t>Cryptocurrency, supply chains, digital identity, and smart contracts.</a:t>
+              <a:t>Artificial Intelligence is a simple idea that can be understood without needing advanced technical knowledge.</a:t>
             </a:r>
           </a:p>
         </p:txBody>
       </p:sp>
       <p:pic>
         <p:nvPicPr>
-          <p:cNvPr id="6" name="Picture 5" descr="web3.png"/>
+          <p:cNvPr id="5" name="Picture 4" descr="web3.png"/>
           <p:cNvPicPr>
             <a:picLocks noChangeAspect="1"/>
           </p:cNvPicPr>
@@ -3872,8 +3837,8 @@
         </p:blipFill>
         <p:spPr>
           <a:xfrm>
-            <a:off x="8138160" y="1828800"/>
-            <a:ext cx="2926080" cy="2926080"/>
+            <a:off x="7955279" y="1234440"/>
+            <a:ext cx="3474720" cy="3474720"/>
           </a:xfrm>
           <a:prstGeom prst="rect">
             <a:avLst/>
@@ -3882,7 +3847,7 @@
       </p:pic>
       <p:pic>
         <p:nvPicPr>
-          <p:cNvPr id="7" name="Picture 6" descr="record.png"/>
+          <p:cNvPr id="6" name="Picture 5" descr="record.png"/>
           <p:cNvPicPr>
             <a:picLocks noChangeAspect="1"/>
           </p:cNvPicPr>
@@ -3906,7 +3871,7 @@
       </p:pic>
       <p:sp>
         <p:nvSpPr>
-          <p:cNvPr id="8" name="TextBox 7"/>
+          <p:cNvPr id="7" name="TextBox 6"/>
           <p:cNvSpPr txBox="1"/>
           <p:nvPr/>
         </p:nvSpPr>
@@ -4016,8 +3981,8 @@
         </p:nvSpPr>
         <p:spPr>
           <a:xfrm>
-            <a:off x="731520" y="548640"/>
-            <a:ext cx="7315200" cy="548640"/>
+            <a:off x="640080" y="548640"/>
+            <a:ext cx="5669280" cy="548640"/>
           </a:xfrm>
           <a:prstGeom prst="rect">
             <a:avLst/>
@@ -4038,7 +4003,7 @@
                 </a:solidFill>
                 <a:latin typeface="Calibri"/>
               </a:rPr>
-              <a:t>Benefits</a:t>
+              <a:t>Key Points / Breakdown</a:t>
             </a:r>
           </a:p>
         </p:txBody>
@@ -4051,8 +4016,8 @@
         </p:nvSpPr>
         <p:spPr>
           <a:xfrm>
-            <a:off x="731520" y="1371600"/>
-            <a:ext cx="4754880" cy="365760"/>
+            <a:off x="640080" y="1463040"/>
+            <a:ext cx="5669280" cy="3474720"/>
           </a:xfrm>
           <a:prstGeom prst="rect">
             <a:avLst/>
@@ -4067,125 +4032,24 @@
           <a:p>
             <a:pPr algn="l"/>
             <a:r>
-              <a:rPr sz="1400" b="1">
-                <a:solidFill>
-                  <a:srgbClr val="FF6600"/>
-                </a:solidFill>
-                <a:latin typeface="Calibri"/>
-              </a:rPr>
-              <a:t>Option A</a:t>
-            </a:r>
-          </a:p>
-        </p:txBody>
-      </p:sp>
-      <p:sp>
-        <p:nvSpPr>
-          <p:cNvPr id="5" name="TextBox 4"/>
-          <p:cNvSpPr txBox="1"/>
-          <p:nvPr/>
-        </p:nvSpPr>
-        <p:spPr>
-          <a:xfrm>
-            <a:off x="6400800" y="1371600"/>
-            <a:ext cx="4754880" cy="365760"/>
-          </a:xfrm>
-          <a:prstGeom prst="rect">
-            <a:avLst/>
-          </a:prstGeom>
-          <a:noFill/>
-        </p:spPr>
-        <p:txBody>
-          <a:bodyPr wrap="none">
-            <a:spAutoFit/>
-          </a:bodyPr>
-          <a:lstStyle/>
-          <a:p>
-            <a:pPr algn="l"/>
-            <a:r>
-              <a:rPr sz="1400" b="1">
-                <a:solidFill>
-                  <a:srgbClr val="FF6600"/>
-                </a:solidFill>
-                <a:latin typeface="Calibri"/>
-              </a:rPr>
-              <a:t>Option B</a:t>
-            </a:r>
-          </a:p>
-        </p:txBody>
-      </p:sp>
-      <p:sp>
-        <p:nvSpPr>
-          <p:cNvPr id="6" name="TextBox 5"/>
-          <p:cNvSpPr txBox="1"/>
-          <p:nvPr/>
-        </p:nvSpPr>
-        <p:spPr>
-          <a:xfrm>
-            <a:off x="731520" y="1828800"/>
-            <a:ext cx="4754880" cy="2926080"/>
-          </a:xfrm>
-          <a:prstGeom prst="rect">
-            <a:avLst/>
-          </a:prstGeom>
-          <a:noFill/>
-        </p:spPr>
-        <p:txBody>
-          <a:bodyPr wrap="none">
-            <a:spAutoFit/>
-          </a:bodyPr>
-          <a:lstStyle/>
-          <a:p>
-            <a:pPr algn="l"/>
-            <a:r>
-              <a:rPr sz="1500" b="0">
+              <a:rPr sz="1600" b="0">
                 <a:solidFill>
                   <a:srgbClr val="141414"/>
                 </a:solidFill>
                 <a:latin typeface="Calibri"/>
               </a:rPr>
-              <a:t>Security, transparency, immut</a:t>
-            </a:r>
-          </a:p>
-        </p:txBody>
-      </p:sp>
-      <p:sp>
-        <p:nvSpPr>
-          <p:cNvPr id="7" name="TextBox 6"/>
-          <p:cNvSpPr txBox="1"/>
-          <p:nvPr/>
-        </p:nvSpPr>
-        <p:spPr>
-          <a:xfrm>
-            <a:off x="6400800" y="1828800"/>
-            <a:ext cx="4754880" cy="2926080"/>
-          </a:xfrm>
-          <a:prstGeom prst="rect">
-            <a:avLst/>
-          </a:prstGeom>
-          <a:noFill/>
-        </p:spPr>
-        <p:txBody>
-          <a:bodyPr wrap="none">
-            <a:spAutoFit/>
-          </a:bodyPr>
-          <a:lstStyle/>
-          <a:p>
-            <a:pPr algn="l"/>
-            <a:r>
-              <a:rPr sz="1500" b="0">
-                <a:solidFill>
-                  <a:srgbClr val="141414"/>
-                </a:solidFill>
-                <a:latin typeface="Calibri"/>
-              </a:rPr>
-              <a:t>ability, and decentralization.</a:t>
+              <a:t>Glossary terms: artificial intelligence</a:t>
+            </a:r>
+            <a:br/>
+            <a:r>
+              <a:t>Analogy categories: general</a:t>
             </a:r>
           </a:p>
         </p:txBody>
       </p:sp>
       <p:pic>
         <p:nvPicPr>
-          <p:cNvPr id="8" name="Picture 7" descr="record.png"/>
+          <p:cNvPr id="5" name="Picture 4" descr="web3.png"/>
           <p:cNvPicPr>
             <a:picLocks noChangeAspect="1"/>
           </p:cNvPicPr>
@@ -4199,17 +4063,41 @@
         </p:blipFill>
         <p:spPr>
           <a:xfrm>
-            <a:off x="10058400" y="365760"/>
-            <a:ext cx="548640" cy="548640"/>
+            <a:off x="7955279" y="1234440"/>
+            <a:ext cx="3474720" cy="3474720"/>
           </a:xfrm>
           <a:prstGeom prst="rect">
             <a:avLst/>
           </a:prstGeom>
         </p:spPr>
       </p:pic>
-      <p:sp>
-        <p:nvSpPr>
-          <p:cNvPr id="9" name="TextBox 8"/>
+      <p:pic>
+        <p:nvPicPr>
+          <p:cNvPr id="6" name="Picture 5" descr="record.png"/>
+          <p:cNvPicPr>
+            <a:picLocks noChangeAspect="1"/>
+          </p:cNvPicPr>
+          <p:nvPr/>
+        </p:nvPicPr>
+        <p:blipFill>
+          <a:blip r:embed="rId3"/>
+          <a:stretch>
+            <a:fillRect/>
+          </a:stretch>
+        </p:blipFill>
+        <p:spPr>
+          <a:xfrm>
+            <a:off x="10058400" y="365760"/>
+            <a:ext cx="548640" cy="548640"/>
+          </a:xfrm>
+          <a:prstGeom prst="rect">
+            <a:avLst/>
+          </a:prstGeom>
+        </p:spPr>
+      </p:pic>
+      <p:sp>
+        <p:nvSpPr>
+          <p:cNvPr id="7" name="TextBox 6"/>
           <p:cNvSpPr txBox="1"/>
           <p:nvPr/>
         </p:nvSpPr>

</xml_diff>